<commit_message>
docs: align submission deck and README with the implemented demo
</commit_message>
<xml_diff>
--- a/Homeward_Design.pptx
+++ b/Homeward_Design.pptx
@@ -2585,7 +2585,7 @@
                   <a:schemeClr val="tx1"/>
                 </a:solidFill>
               </a:rPr>
-              <a:t>Homeward: Technical design</a:t>
+              <a:t>Homeward: implemented demo</a:t>
             </a:r>
             <a:endParaRPr lang="en-US" sz="4400" dirty="0"/>
           </a:p>
@@ -2637,7 +2637,21 @@
                   <a:schemeClr val="tx2"/>
                 </a:solidFill>
               </a:rPr>
-              <a:t>Database → Backend → Frontend of a shelter-run reunification desk</a:t>
+              <a:t>Live: https://hilarious-cassata-a51a3c.netlify.app</a:t>
+            </a:r>
+            <a:endParaRPr lang="en-US" sz="2000" dirty="0"/>
+          </a:p>
+          <a:p>
+            <a:pPr algn="l" indent="0" marL="0">
+              <a:buNone/>
+            </a:pPr>
+            <a:r>
+              <a:rPr lang="en-US" sz="2000" dirty="0">
+                <a:solidFill>
+                  <a:schemeClr val="tx2"/>
+                </a:solidFill>
+              </a:rPr>
+              <a:t>API: https://homeward-api-fjrc.onrender.com</a:t>
             </a:r>
             <a:endParaRPr lang="en-US" sz="2000" dirty="0"/>
           </a:p>
@@ -4485,7 +4499,7 @@
                             <a:schemeClr val="tx1"/>
                           </a:solidFill>
                         </a:rPr>
-                        <a:t>Netlify frontend loads instantly and shows "Connecting. Please wait"; lazy initialization; measured on day 1</a:t>
+                        <a:t>Netlify loads the page and shows "Connecting. Please wait"; lazy initialization; wake before the demo</a:t>
                       </a:r>
                       <a:endParaRPr lang="en-US" sz="1400" dirty="0"/>
                     </a:p>
@@ -4811,7 +4825,7 @@
                   <a:schemeClr val="tx2"/>
                 </a:solidFill>
               </a:rPr>
-              <a:t>re-test on Neon's PostgreSQL version, the data retention job (90 days), re-running searches after new arrivals, issuing codes, adults who can't decide for themselves.</a:t>
+              <a:t>retention job (90 days), automatic re-running of searches, capacity-to-consent policy and scale testing near 400,000 people. Manual Check again and code issuance are built.</a:t>
             </a:r>
             <a:endParaRPr lang="en-US" sz="1600" dirty="0"/>
           </a:p>
@@ -5029,7 +5043,7 @@
                             <a:schemeClr val="bg1"/>
                           </a:solidFill>
                         </a:rPr>
-                        <a:t>React + Vite ✅</a:t>
+                        <a:t>React + Vite (chosen)</a:t>
                       </a:r>
                       <a:endParaRPr lang="en-US" sz="1400" dirty="0"/>
                     </a:p>
@@ -5272,7 +5286,7 @@
                             <a:schemeClr val="tx1"/>
                           </a:solidFill>
                         </a:rPr>
-                        <a:t>✅ Static files</a:t>
+                        <a:t>Static files</a:t>
                       </a:r>
                       <a:endParaRPr lang="en-US" sz="1400" dirty="0"/>
                     </a:p>
@@ -5330,7 +5344,7 @@
                             <a:schemeClr val="tx1"/>
                           </a:solidFill>
                         </a:rPr>
-                        <a:t>🟡 Its own server can sleep too</a:t>
+                        <a:t>Its own server can sleep too</a:t>
                       </a:r>
                       <a:endParaRPr lang="en-US" sz="1400" dirty="0"/>
                     </a:p>
@@ -5388,7 +5402,7 @@
                             <a:schemeClr val="tx1"/>
                           </a:solidFill>
                         </a:rPr>
-                        <a:t>✅ Static files</a:t>
+                        <a:t>Static files</a:t>
                       </a:r>
                       <a:endParaRPr lang="en-US" sz="1400" dirty="0"/>
                     </a:p>
@@ -5506,7 +5520,7 @@
                             <a:schemeClr val="tx1"/>
                           </a:solidFill>
                         </a:rPr>
-                        <a:t>✅</a:t>
+                        <a:t>Yes</a:t>
                       </a:r>
                       <a:endParaRPr lang="en-US" sz="1400" dirty="0"/>
                     </a:p>
@@ -5564,7 +5578,7 @@
                             <a:schemeClr val="tx1"/>
                           </a:solidFill>
                         </a:rPr>
-                        <a:t>✅</a:t>
+                        <a:t>Yes</a:t>
                       </a:r>
                       <a:endParaRPr lang="en-US" sz="1400" dirty="0"/>
                     </a:p>
@@ -5622,7 +5636,7 @@
                             <a:schemeClr val="tx1"/>
                           </a:solidFill>
                         </a:rPr>
-                        <a:t>🟡</a:t>
+                        <a:t>Mixed</a:t>
                       </a:r>
                       <a:endParaRPr lang="en-US" sz="1400" dirty="0"/>
                     </a:p>
@@ -5740,7 +5754,7 @@
                             <a:schemeClr val="tx1"/>
                           </a:solidFill>
                         </a:rPr>
-                        <a:t>🟡 Code-split per page</a:t>
+                        <a:t>~133 KB gzip bundle</a:t>
                       </a:r>
                       <a:endParaRPr lang="en-US" sz="1400" dirty="0"/>
                     </a:p>
@@ -5798,7 +5812,7 @@
                             <a:schemeClr val="tx1"/>
                           </a:solidFill>
                         </a:rPr>
-                        <a:t>🟡</a:t>
+                        <a:t>Mixed</a:t>
                       </a:r>
                       <a:endParaRPr lang="en-US" sz="1400" dirty="0"/>
                     </a:p>
@@ -5856,7 +5870,7 @@
                             <a:schemeClr val="tx1"/>
                           </a:solidFill>
                         </a:rPr>
-                        <a:t>✅</a:t>
+                        <a:t>Yes</a:t>
                       </a:r>
                       <a:endParaRPr lang="en-US" sz="1400" dirty="0"/>
                     </a:p>
@@ -5946,7 +5960,7 @@
                   <a:schemeClr val="tx2"/>
                 </a:solidFill>
               </a:rPr>
-              <a:t>survivors have no phones, any shelter laptop or tablet works with nothing to install, and it can print slips and paper forms.</a:t>
+              <a:t>survivors may have no phone; a shelter laptop or tablet works with nothing to install. It prints reunion slips and supports entry from paper.</a:t>
             </a:r>
             <a:endParaRPr lang="en-US" sz="1600" dirty="0"/>
           </a:p>
@@ -6873,7 +6887,7 @@
                             <a:schemeClr val="tx1"/>
                           </a:solidFill>
                         </a:rPr>
-                        <a:t>Make the wrong thing impossible</a:t>
+                        <a:t>Reduce predictable mistakes</a:t>
                       </a:r>
                       <a:endParaRPr lang="en-US" sz="1400" dirty="0"/>
                     </a:p>
@@ -9035,7 +9049,7 @@
                             <a:schemeClr val="tx1"/>
                           </a:solidFill>
                         </a:rPr>
-                        <a:t>"Ask me first" pre-selected; the searcher's screen has no location field and is always fresh</a:t>
+                        <a:t>"Ask me first" pre-selected; only consent reveals a contact plan; old status is cleared during refresh</a:t>
                       </a:r>
                       <a:endParaRPr lang="en-US" sz="1400" dirty="0"/>
                     </a:p>
@@ -9505,7 +9519,7 @@
                             <a:schemeClr val="tx1"/>
                           </a:solidFill>
                         </a:rPr>
-                        <a:t>Paper mode, blank form</a:t>
+                        <a:t>Paper-entry mode</a:t>
                       </a:r>
                       <a:endParaRPr lang="en-US" sz="1400" dirty="0"/>
                     </a:p>
@@ -10066,7 +10080,7 @@
                   <a:schemeClr val="tx1"/>
                 </a:solidFill>
               </a:rPr>
-              <a:t>Tradeoffs, and how I'll test it</a:t>
+              <a:t>Verified now; usability study next</a:t>
             </a:r>
             <a:endParaRPr lang="en-US" sz="3200" dirty="0"/>
           </a:p>
@@ -10295,7 +10309,7 @@
                             <a:schemeClr val="tx1"/>
                           </a:solidFill>
                         </a:rPr>
-                        <a:t>What's there works without training; the rest is listed as Later</a:t>
+                        <a:t>Core flow verified; usability with non-experts still needs testing</a:t>
                       </a:r>
                       <a:endParaRPr lang="en-US" sz="1400" dirty="0"/>
                     </a:p>
@@ -10610,7 +10624,7 @@
                   <a:schemeClr val="tx2"/>
                 </a:solidFill>
               </a:rPr>
-              <a:t>Later: </a:t>
+              <a:t xml:space="preserve">Verified: </a:t>
             </a:r>
             <a:pPr indent="0" marL="0">
               <a:buNone/>
@@ -10621,7 +10635,7 @@
                   <a:schemeClr val="tx2"/>
                 </a:solidFill>
               </a:rPr>
-              <a:t>offline mode, undo history, Spanish, household links, a self-service "I'm safe" page.</a:t>
+              <a:t>155 SQL checks, 52 backend tests, 26 UI tests; a reunion completed across three live desks.</a:t>
             </a:r>
             <a:endParaRPr lang="en-US" sz="1600" dirty="0"/>
           </a:p>
@@ -10635,7 +10649,7 @@
                   <a:schemeClr val="tx2"/>
                 </a:solidFill>
               </a:rPr>
-              <a:t>Will test with 3–5 non-experts: </a:t>
+              <a:t xml:space="preserve">Still planned: </a:t>
             </a:r>
             <a:pPr indent="0" marL="0">
               <a:buNone/>
@@ -10646,7 +10660,7 @@
                   <a:schemeClr val="tx2"/>
                 </a:solidFill>
               </a:rPr>
-              <a:t>register Rosa in under 2 minutes, search for Mia, check a slip code, reload mid-form, come back to a locked screen, copy two paper forms by keyboard.</a:t>
+              <a:t>3–5 non-expert usability sessions; printable blank form, full offline mode, retention job and translations.</a:t>
             </a:r>
             <a:endParaRPr lang="en-US" sz="1600" dirty="0"/>
           </a:p>
@@ -11142,7 +11156,7 @@
                   <a:schemeClr val="tx2"/>
                 </a:solidFill>
               </a:rPr>
-              <a:t>The searcher's screen has no location field; locks after 10 minutes</a:t>
+              <a:t>Only consent reveals a contact plan; screen locks after 10 minutes</a:t>
             </a:r>
             <a:endParaRPr lang="en-US" sz="1200" dirty="0"/>
           </a:p>
@@ -12225,7 +12239,7 @@
                             <a:schemeClr val="tx1"/>
                           </a:solidFill>
                         </a:rPr>
-                        <a:t>Flyway (V1__init.sql)</a:t>
+                        <a:t>Flyway V1–V5 (owner-run)</a:t>
                       </a:r>
                       <a:endParaRPr lang="en-US" sz="1400" dirty="0"/>
                     </a:p>
@@ -12401,7 +12415,7 @@
                             <a:schemeClr val="tx1"/>
                           </a:solidFill>
                         </a:rPr>
-                        <a:t>Kotlin 2.2+ · Spring Boot 4 + Spring Security 7</a:t>
+                        <a:t>Kotlin 2.3.21 · Spring Boot 4 + Spring Security 7</a:t>
                       </a:r>
                       <a:endParaRPr lang="en-US" sz="1400" dirty="0"/>
                     </a:p>
@@ -12459,7 +12473,7 @@
                             <a:schemeClr val="tx1"/>
                           </a:solidFill>
                         </a:rPr>
-                        <a:t>Null safety for "unknown"; a searcher's reply has no location field; proven login and roles</a:t>
+                        <a:t>Null safety for "unknown"; only consent can reveal a contact plan; tested login and roles</a:t>
                       </a:r>
                       <a:endParaRPr lang="en-US" sz="1400" dirty="0"/>
                     </a:p>
@@ -13105,7 +13119,7 @@
                             <a:schemeClr val="tx1"/>
                           </a:solidFill>
                         </a:rPr>
-                        <a:t>Testcontainers (real Postgres) · Vitest · 3–5 non-experts</a:t>
+                        <a:t>155 SQL checks · 52 backend tests · 26 UI tests</a:t>
                       </a:r>
                       <a:endParaRPr lang="en-US" sz="1400" dirty="0"/>
                     </a:p>
@@ -13163,7 +13177,7 @@
                             <a:schemeClr val="tx1"/>
                           </a:solidFill>
                         </a:rPr>
-                        <a:t>Privacy rules tested for real; usability tested with people</a:t>
+                        <a:t>PostgreSQL 18.6; live reunion verified; usability study planned</a:t>
                       </a:r>
                       <a:endParaRPr lang="en-US" sz="1400" dirty="0"/>
                     </a:p>
@@ -13600,7 +13614,7 @@
                             <a:schemeClr val="bg1"/>
                           </a:solidFill>
                         </a:rPr>
-                        <a:t>PostgreSQL ✅</a:t>
+                        <a:t>PostgreSQL (chosen)</a:t>
                       </a:r>
                       <a:endParaRPr lang="en-US" sz="1400" dirty="0"/>
                     </a:p>
@@ -13843,7 +13857,7 @@
                             <a:schemeClr val="tx1"/>
                           </a:solidFill>
                         </a:rPr>
-                        <a:t>✅ pg_trgm + dmetaphone in SQL</a:t>
+                        <a:t>pg_trgm + dmetaphone in SQL</a:t>
                       </a:r>
                       <a:endParaRPr lang="en-US" sz="1400" dirty="0"/>
                     </a:p>
@@ -13901,7 +13915,7 @@
                             <a:schemeClr val="tx1"/>
                           </a:solidFill>
                         </a:rPr>
-                        <a:t>🟡 SOUNDEX only</a:t>
+                        <a:t>SOUNDEX only</a:t>
                       </a:r>
                       <a:endParaRPr lang="en-US" sz="1400" dirty="0"/>
                     </a:p>
@@ -13959,7 +13973,7 @@
                             <a:schemeClr val="tx1"/>
                           </a:solidFill>
                         </a:rPr>
-                        <a:t>🟡 Atlas Search, separate index</a:t>
+                        <a:t>Atlas Search, separate index</a:t>
                       </a:r>
                       <a:endParaRPr lang="en-US" sz="1400" dirty="0"/>
                     </a:p>
@@ -14077,7 +14091,7 @@
                             <a:schemeClr val="tx1"/>
                           </a:solidFill>
                         </a:rPr>
-                        <a:t>✅ CHECK, triggers, views, grants</a:t>
+                        <a:t>CHECK, triggers, views, grants</a:t>
                       </a:r>
                       <a:endParaRPr lang="en-US" sz="1400" dirty="0"/>
                     </a:p>
@@ -14135,7 +14149,7 @@
                             <a:schemeClr val="tx1"/>
                           </a:solidFill>
                         </a:rPr>
-                        <a:t>✅ CHECK, triggers, grants</a:t>
+                        <a:t>CHECK, triggers, grants</a:t>
                       </a:r>
                       <a:endParaRPr lang="en-US" sz="1400" dirty="0"/>
                     </a:p>
@@ -14193,7 +14207,7 @@
                             <a:schemeClr val="tx1"/>
                           </a:solidFill>
                         </a:rPr>
-                        <a:t>🟡 Schema validation only</a:t>
+                        <a:t>Schema validation only</a:t>
                       </a:r>
                       <a:endParaRPr lang="en-US" sz="1400" dirty="0"/>
                     </a:p>
@@ -14311,7 +14325,7 @@
                             <a:schemeClr val="tx1"/>
                           </a:solidFill>
                         </a:rPr>
-                        <a:t>✅ Neon</a:t>
+                        <a:t>Neon</a:t>
                       </a:r>
                       <a:endParaRPr lang="en-US" sz="1400" dirty="0"/>
                     </a:p>
@@ -14369,7 +14383,7 @@
                             <a:schemeClr val="tx1"/>
                           </a:solidFill>
                         </a:rPr>
-                        <a:t>🟡 Fewer good free tiers</a:t>
+                        <a:t>Fewer good free tiers</a:t>
                       </a:r>
                       <a:endParaRPr lang="en-US" sz="1400" dirty="0"/>
                     </a:p>
@@ -14427,7 +14441,7 @@
                             <a:schemeClr val="tx1"/>
                           </a:solidFill>
                         </a:rPr>
-                        <a:t>✅ Atlas M0</a:t>
+                        <a:t>Atlas M0</a:t>
                       </a:r>
                       <a:endParaRPr lang="en-US" sz="1400" dirty="0"/>
                     </a:p>
@@ -17795,7 +17809,7 @@
                             <a:schemeClr val="bg1"/>
                           </a:solidFill>
                         </a:rPr>
-                        <a:t>Kotlin + Spring Boot ✅</a:t>
+                        <a:t>Kotlin + Spring Boot (chosen)</a:t>
                       </a:r>
                       <a:endParaRPr lang="en-US" sz="1400" dirty="0"/>
                     </a:p>
@@ -17980,7 +17994,7 @@
                             <a:schemeClr val="tx1"/>
                           </a:solidFill>
                         </a:rPr>
-                        <a:t>Can't leak a location by accident</a:t>
+                        <a:t>Keep location out of match replies</a:t>
                       </a:r>
                       <a:endParaRPr lang="en-US" sz="1400" dirty="0"/>
                     </a:p>
@@ -18038,7 +18052,7 @@
                             <a:schemeClr val="tx1"/>
                           </a:solidFill>
                         </a:rPr>
-                        <a:t>✅ No location fields (compile-time)</a:t>
+                        <a:t>Dedicated match response types</a:t>
                       </a:r>
                       <a:endParaRPr lang="en-US" sz="1400" dirty="0"/>
                     </a:p>
@@ -18096,7 +18110,7 @@
                             <a:schemeClr val="tx1"/>
                           </a:solidFill>
                         </a:rPr>
-                        <a:t>🟡 Tests only</a:t>
+                        <a:t>Tests only</a:t>
                       </a:r>
                       <a:endParaRPr lang="en-US" sz="1400" dirty="0"/>
                     </a:p>
@@ -18154,7 +18168,7 @@
                             <a:schemeClr val="tx1"/>
                           </a:solidFill>
                         </a:rPr>
-                        <a:t>🟡 Runtime filter (response_model)</a:t>
+                        <a:t>Runtime filter (response_model)</a:t>
                       </a:r>
                       <a:endParaRPr lang="en-US" sz="1400" dirty="0"/>
                     </a:p>
@@ -18214,7 +18228,7 @@
                             <a:schemeClr val="tx1"/>
                           </a:solidFill>
                         </a:rPr>
-                        <a:t>Login, roles, idle lock without custom security code</a:t>
+                        <a:t>Framework support for login and roles</a:t>
                       </a:r>
                       <a:endParaRPr lang="en-US" sz="1400" dirty="0"/>
                     </a:p>
@@ -18272,7 +18286,7 @@
                             <a:schemeClr val="tx1"/>
                           </a:solidFill>
                         </a:rPr>
-                        <a:t>✅ Spring Security</a:t>
+                        <a:t>Spring Security</a:t>
                       </a:r>
                       <a:endParaRPr lang="en-US" sz="1400" dirty="0"/>
                     </a:p>
@@ -18330,7 +18344,7 @@
                             <a:schemeClr val="tx1"/>
                           </a:solidFill>
                         </a:rPr>
-                        <a:t>🟡 Passport + guards</a:t>
+                        <a:t>Passport + guards</a:t>
                       </a:r>
                       <a:endParaRPr lang="en-US" sz="1400" dirty="0"/>
                     </a:p>
@@ -18388,7 +18402,7 @@
                             <a:schemeClr val="tx1"/>
                           </a:solidFill>
                         </a:rPr>
-                        <a:t>🟡 Build most of it</a:t>
+                        <a:t>Build most of it</a:t>
                       </a:r>
                       <a:endParaRPr lang="en-US" sz="1400" dirty="0"/>
                     </a:p>
@@ -18506,7 +18520,7 @@
                             <a:schemeClr val="tx1"/>
                           </a:solidFill>
                         </a:rPr>
-                        <a:t>❌ Slow JVM start</a:t>
+                        <a:t>Slow JVM start</a:t>
                       </a:r>
                       <a:endParaRPr lang="en-US" sz="1400" dirty="0"/>
                     </a:p>
@@ -18564,7 +18578,7 @@
                             <a:schemeClr val="tx1"/>
                           </a:solidFill>
                         </a:rPr>
-                        <a:t>✅</a:t>
+                        <a:t>Yes</a:t>
                       </a:r>
                       <a:endParaRPr lang="en-US" sz="1400" dirty="0"/>
                     </a:p>
@@ -18622,7 +18636,7 @@
                             <a:schemeClr val="tx1"/>
                           </a:solidFill>
                         </a:rPr>
-                        <a:t>✅</a:t>
+                        <a:t>Yes</a:t>
                       </a:r>
                       <a:endParaRPr lang="en-US" sz="1400" dirty="0"/>
                     </a:p>
@@ -18712,7 +18726,7 @@
                   <a:schemeClr val="tx2"/>
                 </a:solidFill>
               </a:rPr>
-              <a:t>Fallback: if the cold start is too slow on day 1, switch to Kotlin + Ktor. Language, types, SQL and schema stay the same.</a:t>
+              <a:t>Live on Render: health and the full reunion verified. Wake the demo a minute early; the page shows Connecting while the backend starts.</a:t>
             </a:r>
             <a:endParaRPr lang="en-US" sz="1600" dirty="0"/>
           </a:p>
@@ -18820,7 +18834,7 @@
                   <a:schemeClr val="tx1"/>
                 </a:solidFill>
               </a:rPr>
-              <a:t>Which class does what</a:t>
+              <a:t>Implemented classes, grouped by responsibility</a:t>
             </a:r>
             <a:endParaRPr lang="en-US" sz="3200" dirty="0"/>
           </a:p>
@@ -19092,7 +19106,7 @@
                   <a:schemeClr val="accent3"/>
                 </a:solidFill>
               </a:rPr>
-              <a:t>web/</a:t>
+              <a:t>Controllers</a:t>
             </a:r>
             <a:endParaRPr lang="en-US" sz="1200" dirty="0"/>
           </a:p>
@@ -19136,7 +19150,7 @@
                   <a:schemeClr val="tx1"/>
                 </a:solidFill>
               </a:rPr>
-              <a:t>RegisterController</a:t>
+              <a:t>PersonController</a:t>
             </a:r>
             <a:endParaRPr lang="en-US" sz="1200" dirty="0"/>
           </a:p>
@@ -19208,7 +19222,7 @@
                   <a:schemeClr val="tx2"/>
                 </a:solidFill>
               </a:rPr>
-              <a:t>"I'm looking for someone" + status</a:t>
+              <a:t>Search + requests</a:t>
             </a:r>
             <a:endParaRPr lang="en-US" sz="1200" dirty="0"/>
           </a:p>
@@ -19252,7 +19266,7 @@
                   <a:schemeClr val="tx1"/>
                 </a:solidFill>
               </a:rPr>
-              <a:t>LookupController</a:t>
+              <a:t>ConsentController</a:t>
             </a:r>
             <a:endParaRPr lang="en-US" sz="1200" dirty="0"/>
           </a:p>
@@ -19266,7 +19280,7 @@
                   <a:schemeClr val="tx2"/>
                 </a:solidFill>
               </a:rPr>
-              <a:t>Code + PIN at the desk</a:t>
+              <a:t>Status, answers, slip lookup</a:t>
             </a:r>
             <a:endParaRPr lang="en-US" sz="1200" dirty="0"/>
           </a:p>
@@ -19324,7 +19338,7 @@
                   <a:schemeClr val="tx2"/>
                 </a:solidFill>
               </a:rPr>
-              <a:t>Matches, minors, reissue</a:t>
+              <a:t>Flags, minors, reissue</a:t>
             </a:r>
             <a:endParaRPr lang="en-US" sz="1200" dirty="0"/>
           </a:p>
@@ -19382,7 +19396,7 @@
                   <a:schemeClr val="tx2"/>
                 </a:solidFill>
               </a:rPr>
-              <a:t>Only reply to searchers: no location fields</a:t>
+              <a:t>Only consent can carry a contact plan</a:t>
             </a:r>
             <a:endParaRPr lang="en-US" sz="1200" dirty="0"/>
           </a:p>
@@ -19442,7 +19456,7 @@
                   <a:schemeClr val="accent3"/>
                 </a:solidFill>
               </a:rPr>
-              <a:t>service/</a:t>
+              <a:t>Services</a:t>
             </a:r>
             <a:endParaRPr lang="en-US" sz="1200" dirty="0"/>
           </a:p>
@@ -19500,7 +19514,7 @@
                   <a:schemeClr val="tx2"/>
                 </a:solidFill>
               </a:rPr>
-              <a:t>Decides what a searcher sees; checks the desk or their slip, and flags</a:t>
+              <a:t>consent/: desk or slip proof, consent and protection checks</a:t>
             </a:r>
             <a:endParaRPr lang="en-US" sz="1200" dirty="0"/>
           </a:p>
@@ -19558,7 +19572,7 @@
                   <a:schemeClr val="tx2"/>
                 </a:solidFill>
               </a:rPr>
-              <a:t>Connect / Safe / Say no; "findable" = yes in advance; a child needs a lead</a:t>
+              <a:t>consent/: decisions; advance consent; lead for a child</a:t>
             </a:r>
             <a:endParaRPr lang="en-US" sz="1200" dirty="0"/>
           </a:p>
@@ -19616,7 +19630,7 @@
                   <a:schemeClr val="tx2"/>
                 </a:solidFill>
               </a:rPr>
-              <a:t>Code + PIN; 5-try lock; same reply on a miss</a:t>
+              <a:t>person/: code + PIN; 5-try lock; identical miss reply</a:t>
             </a:r>
             <a:endParaRPr lang="en-US" sz="1200" dirty="0"/>
           </a:p>
@@ -19674,7 +19688,7 @@
                   <a:schemeClr val="tx2"/>
                 </a:solidFill>
               </a:rPr>
-              <a:t>Fuzzy name + age clues; only suggests</a:t>
+              <a:t>match/: fuzzy name + age clues; only suggests</a:t>
             </a:r>
             <a:endParaRPr lang="en-US" sz="1200" dirty="0"/>
           </a:p>
@@ -19732,7 +19746,7 @@
                   <a:schemeClr val="tx2"/>
                 </a:solidFill>
               </a:rPr>
-              <a:t>Logs every search, lookup and reveal</a:t>
+              <a:t>audit/: search, lookup and reveal events</a:t>
             </a:r>
             <a:endParaRPr lang="en-US" sz="1200" dirty="0"/>
           </a:p>
@@ -19792,7 +19806,7 @@
                   <a:schemeClr val="accent3"/>
                 </a:solidFill>
               </a:rPr>
-              <a:t>repo/</a:t>
+              <a:t>Data access</a:t>
             </a:r>
             <a:endParaRPr lang="en-US" sz="1200" dirty="0"/>
           </a:p>
@@ -19952,7 +19966,7 @@
                   <a:schemeClr val="tx1"/>
                 </a:solidFill>
               </a:rPr>
-              <a:t>ContactRequestRepo</a:t>
+              <a:t>ConsentRepo</a:t>
             </a:r>
             <a:endParaRPr lang="en-US" sz="1200" dirty="0"/>
           </a:p>
@@ -20010,7 +20024,7 @@
                   <a:schemeClr val="tx1"/>
                 </a:solidFill>
               </a:rPr>
-              <a:t>ReunionCodeRepo</a:t>
+              <a:t>ReunionCodeService</a:t>
             </a:r>
             <a:endParaRPr lang="en-US" sz="1200" dirty="0"/>
           </a:p>
@@ -20068,7 +20082,7 @@
                   <a:schemeClr val="tx1"/>
                 </a:solidFill>
               </a:rPr>
-              <a:t>SafetyFlagRepo</a:t>
+              <a:t>LeadService</a:t>
             </a:r>
             <a:endParaRPr lang="en-US" sz="1200" dirty="0"/>
           </a:p>
@@ -20186,7 +20200,7 @@
                   <a:schemeClr val="tx1"/>
                 </a:solidFill>
               </a:rPr>
-              <a:t>PostgreSQL on Neon (Flyway V1__init.sql)</a:t>
+              <a:t>PostgreSQL 18.6 on Neon · Flyway V1–V5</a:t>
             </a:r>
             <a:endParaRPr lang="en-US" sz="1200" dirty="0"/>
           </a:p>

</xml_diff>